<commit_message>
Trieed to make ResNet autoencoderanddecoder but...
</commit_message>
<xml_diff>
--- a/power_point_folder/power_point_project.pptx
+++ b/power_point_folder/power_point_project.pptx
@@ -12,6 +12,8 @@
     <p:sldId id="260" r:id="rId6"/>
     <p:sldId id="262" r:id="rId7"/>
     <p:sldId id="261" r:id="rId8"/>
+    <p:sldId id="263" r:id="rId9"/>
+    <p:sldId id="264" r:id="rId10"/>
   </p:sldIdLst>
   <p:sldSz cx="12192000" cy="6858000"/>
   <p:notesSz cx="6858000" cy="9144000"/>
@@ -113,12 +115,20 @@
 </p:presentation>
 </file>
 
+<file path=ppt/revisionInfo.xml><?xml version="1.0" encoding="utf-8"?>
+<p1510:revInfo xmlns:a="http://schemas.openxmlformats.org/drawingml/2006/main" xmlns:r="http://schemas.openxmlformats.org/officeDocument/2006/relationships" xmlns:p1510="http://schemas.microsoft.com/office/powerpoint/2015/10/main">
+  <p1510:revLst>
+    <p1510:client id="{D3521796-5F0E-439D-A398-16F68E4E77DC}" v="2" dt="2026-06-01T12:22:28.980"/>
+  </p1510:revLst>
+</p1510:revInfo>
+</file>
+
 <file path=ppt/changesInfos/changesInfo1.xml><?xml version="1.0" encoding="utf-8"?>
 <pc:chgInfo xmlns:a="http://schemas.openxmlformats.org/drawingml/2006/main" xmlns:r="http://schemas.openxmlformats.org/officeDocument/2006/relationships" xmlns:ac="http://schemas.microsoft.com/office/drawing/2013/main/command" xmlns:pc="http://schemas.microsoft.com/office/powerpoint/2013/main/command">
   <pc:docChgLst>
     <pc:chgData name="Ulrik Steen Andersen" userId="66700c71-4b67-4d05-a025-65cca66a2d9e" providerId="ADAL" clId="{40447571-E4A6-4F32-A1D1-C8BB8A79932B}"/>
-    <pc:docChg chg="custSel addSld modSld">
-      <pc:chgData name="Ulrik Steen Andersen" userId="66700c71-4b67-4d05-a025-65cca66a2d9e" providerId="ADAL" clId="{40447571-E4A6-4F32-A1D1-C8BB8A79932B}" dt="2026-06-01T12:02:12.790" v="530" actId="20577"/>
+    <pc:docChg chg="undo custSel addSld modSld">
+      <pc:chgData name="Ulrik Steen Andersen" userId="66700c71-4b67-4d05-a025-65cca66a2d9e" providerId="ADAL" clId="{40447571-E4A6-4F32-A1D1-C8BB8A79932B}" dt="2026-06-01T12:37:20.068" v="771" actId="1076"/>
       <pc:docMkLst>
         <pc:docMk/>
       </pc:docMkLst>
@@ -198,30 +208,102 @@
           </ac:spMkLst>
         </pc:spChg>
       </pc:sldChg>
-      <pc:sldChg chg="modSp new mod">
-        <pc:chgData name="Ulrik Steen Andersen" userId="66700c71-4b67-4d05-a025-65cca66a2d9e" providerId="ADAL" clId="{40447571-E4A6-4F32-A1D1-C8BB8A79932B}" dt="2026-06-01T11:57:30.550" v="233" actId="20577"/>
+      <pc:sldChg chg="addSp delSp modSp new mod setBg">
+        <pc:chgData name="Ulrik Steen Andersen" userId="66700c71-4b67-4d05-a025-65cca66a2d9e" providerId="ADAL" clId="{40447571-E4A6-4F32-A1D1-C8BB8A79932B}" dt="2026-06-01T12:37:20.068" v="771" actId="1076"/>
         <pc:sldMkLst>
           <pc:docMk/>
           <pc:sldMk cId="3796435232" sldId="260"/>
         </pc:sldMkLst>
-        <pc:spChg chg="mod">
-          <ac:chgData name="Ulrik Steen Andersen" userId="66700c71-4b67-4d05-a025-65cca66a2d9e" providerId="ADAL" clId="{40447571-E4A6-4F32-A1D1-C8BB8A79932B}" dt="2026-06-01T11:57:30.550" v="233" actId="20577"/>
+        <pc:spChg chg="mod ord">
+          <ac:chgData name="Ulrik Steen Andersen" userId="66700c71-4b67-4d05-a025-65cca66a2d9e" providerId="ADAL" clId="{40447571-E4A6-4F32-A1D1-C8BB8A79932B}" dt="2026-06-01T12:37:06.105" v="768" actId="14100"/>
           <ac:spMkLst>
             <pc:docMk/>
             <pc:sldMk cId="3796435232" sldId="260"/>
             <ac:spMk id="2" creationId="{16DA5B2F-C13B-8A3B-2ACE-C89173C187A0}"/>
           </ac:spMkLst>
         </pc:spChg>
+        <pc:spChg chg="del">
+          <ac:chgData name="Ulrik Steen Andersen" userId="66700c71-4b67-4d05-a025-65cca66a2d9e" providerId="ADAL" clId="{40447571-E4A6-4F32-A1D1-C8BB8A79932B}" dt="2026-06-01T12:35:53.539" v="746" actId="931"/>
+          <ac:spMkLst>
+            <pc:docMk/>
+            <pc:sldMk cId="3796435232" sldId="260"/>
+            <ac:spMk id="3" creationId="{EC28A938-EDEC-EB58-0B84-D2AF20C753E7}"/>
+          </ac:spMkLst>
+        </pc:spChg>
+        <pc:spChg chg="add del">
+          <ac:chgData name="Ulrik Steen Andersen" userId="66700c71-4b67-4d05-a025-65cca66a2d9e" providerId="ADAL" clId="{40447571-E4A6-4F32-A1D1-C8BB8A79932B}" dt="2026-06-01T12:36:53.320" v="764" actId="26606"/>
+          <ac:spMkLst>
+            <pc:docMk/>
+            <pc:sldMk cId="3796435232" sldId="260"/>
+            <ac:spMk id="10" creationId="{37C89E4B-3C9F-44B9-8B86-D9E3D112D8EC}"/>
+          </ac:spMkLst>
+        </pc:spChg>
+        <pc:spChg chg="add del">
+          <ac:chgData name="Ulrik Steen Andersen" userId="66700c71-4b67-4d05-a025-65cca66a2d9e" providerId="ADAL" clId="{40447571-E4A6-4F32-A1D1-C8BB8A79932B}" dt="2026-06-01T12:36:51.905" v="761" actId="26606"/>
+          <ac:spMkLst>
+            <pc:docMk/>
+            <pc:sldMk cId="3796435232" sldId="260"/>
+            <ac:spMk id="19" creationId="{37C89E4B-3C9F-44B9-8B86-D9E3D112D8EC}"/>
+          </ac:spMkLst>
+        </pc:spChg>
+        <pc:picChg chg="add mod ord">
+          <ac:chgData name="Ulrik Steen Andersen" userId="66700c71-4b67-4d05-a025-65cca66a2d9e" providerId="ADAL" clId="{40447571-E4A6-4F32-A1D1-C8BB8A79932B}" dt="2026-06-01T12:37:20.068" v="771" actId="1076"/>
+          <ac:picMkLst>
+            <pc:docMk/>
+            <pc:sldMk cId="3796435232" sldId="260"/>
+            <ac:picMk id="5" creationId="{ECF230BF-30BC-7678-54DF-27651DC18941}"/>
+          </ac:picMkLst>
+        </pc:picChg>
+        <pc:cxnChg chg="add del">
+          <ac:chgData name="Ulrik Steen Andersen" userId="66700c71-4b67-4d05-a025-65cca66a2d9e" providerId="ADAL" clId="{40447571-E4A6-4F32-A1D1-C8BB8A79932B}" dt="2026-06-01T12:36:53.320" v="764" actId="26606"/>
+          <ac:cxnSpMkLst>
+            <pc:docMk/>
+            <pc:sldMk cId="3796435232" sldId="260"/>
+            <ac:cxnSpMk id="12" creationId="{AA2EAA10-076F-46BD-8F0F-B9A2FB77A85C}"/>
+          </ac:cxnSpMkLst>
+        </pc:cxnChg>
+        <pc:cxnChg chg="add del">
+          <ac:chgData name="Ulrik Steen Andersen" userId="66700c71-4b67-4d05-a025-65cca66a2d9e" providerId="ADAL" clId="{40447571-E4A6-4F32-A1D1-C8BB8A79932B}" dt="2026-06-01T12:36:53.320" v="764" actId="26606"/>
+          <ac:cxnSpMkLst>
+            <pc:docMk/>
+            <pc:sldMk cId="3796435232" sldId="260"/>
+            <ac:cxnSpMk id="14" creationId="{D891E407-403B-4764-86C9-33A56D3BCAA3}"/>
+          </ac:cxnSpMkLst>
+        </pc:cxnChg>
+        <pc:cxnChg chg="add del">
+          <ac:chgData name="Ulrik Steen Andersen" userId="66700c71-4b67-4d05-a025-65cca66a2d9e" providerId="ADAL" clId="{40447571-E4A6-4F32-A1D1-C8BB8A79932B}" dt="2026-06-01T12:36:51.905" v="761" actId="26606"/>
+          <ac:cxnSpMkLst>
+            <pc:docMk/>
+            <pc:sldMk cId="3796435232" sldId="260"/>
+            <ac:cxnSpMk id="21" creationId="{AA2EAA10-076F-46BD-8F0F-B9A2FB77A85C}"/>
+          </ac:cxnSpMkLst>
+        </pc:cxnChg>
+        <pc:cxnChg chg="add del">
+          <ac:chgData name="Ulrik Steen Andersen" userId="66700c71-4b67-4d05-a025-65cca66a2d9e" providerId="ADAL" clId="{40447571-E4A6-4F32-A1D1-C8BB8A79932B}" dt="2026-06-01T12:36:51.905" v="761" actId="26606"/>
+          <ac:cxnSpMkLst>
+            <pc:docMk/>
+            <pc:sldMk cId="3796435232" sldId="260"/>
+            <ac:cxnSpMk id="23" creationId="{D891E407-403B-4764-86C9-33A56D3BCAA3}"/>
+          </ac:cxnSpMkLst>
+        </pc:cxnChg>
       </pc:sldChg>
-      <pc:sldChg chg="new">
-        <pc:chgData name="Ulrik Steen Andersen" userId="66700c71-4b67-4d05-a025-65cca66a2d9e" providerId="ADAL" clId="{40447571-E4A6-4F32-A1D1-C8BB8A79932B}" dt="2026-06-01T11:55:59.572" v="109" actId="680"/>
+      <pc:sldChg chg="modSp new mod">
+        <pc:chgData name="Ulrik Steen Andersen" userId="66700c71-4b67-4d05-a025-65cca66a2d9e" providerId="ADAL" clId="{40447571-E4A6-4F32-A1D1-C8BB8A79932B}" dt="2026-06-01T12:33:34.831" v="745" actId="20577"/>
         <pc:sldMkLst>
           <pc:docMk/>
           <pc:sldMk cId="2214895637" sldId="261"/>
         </pc:sldMkLst>
+        <pc:spChg chg="mod">
+          <ac:chgData name="Ulrik Steen Andersen" userId="66700c71-4b67-4d05-a025-65cca66a2d9e" providerId="ADAL" clId="{40447571-E4A6-4F32-A1D1-C8BB8A79932B}" dt="2026-06-01T12:33:34.831" v="745" actId="20577"/>
+          <ac:spMkLst>
+            <pc:docMk/>
+            <pc:sldMk cId="2214895637" sldId="261"/>
+            <ac:spMk id="2" creationId="{F13E44ED-EB60-15E1-C51F-14527F24DFA4}"/>
+          </ac:spMkLst>
+        </pc:spChg>
       </pc:sldChg>
       <pc:sldChg chg="modSp new mod">
-        <pc:chgData name="Ulrik Steen Andersen" userId="66700c71-4b67-4d05-a025-65cca66a2d9e" providerId="ADAL" clId="{40447571-E4A6-4F32-A1D1-C8BB8A79932B}" dt="2026-06-01T12:02:12.790" v="530" actId="20577"/>
+        <pc:chgData name="Ulrik Steen Andersen" userId="66700c71-4b67-4d05-a025-65cca66a2d9e" providerId="ADAL" clId="{40447571-E4A6-4F32-A1D1-C8BB8A79932B}" dt="2026-06-01T12:22:44.517" v="725" actId="20577"/>
         <pc:sldMkLst>
           <pc:docMk/>
           <pc:sldMk cId="4046370384" sldId="262"/>
@@ -235,7 +317,7 @@
           </ac:spMkLst>
         </pc:spChg>
         <pc:spChg chg="mod">
-          <ac:chgData name="Ulrik Steen Andersen" userId="66700c71-4b67-4d05-a025-65cca66a2d9e" providerId="ADAL" clId="{40447571-E4A6-4F32-A1D1-C8BB8A79932B}" dt="2026-06-01T12:02:09.569" v="522" actId="20577"/>
+          <ac:chgData name="Ulrik Steen Andersen" userId="66700c71-4b67-4d05-a025-65cca66a2d9e" providerId="ADAL" clId="{40447571-E4A6-4F32-A1D1-C8BB8A79932B}" dt="2026-06-01T12:22:41.344" v="721" actId="20577"/>
           <ac:spMkLst>
             <pc:docMk/>
             <pc:sldMk cId="4046370384" sldId="262"/>
@@ -243,13 +325,27 @@
           </ac:spMkLst>
         </pc:spChg>
         <pc:spChg chg="mod">
-          <ac:chgData name="Ulrik Steen Andersen" userId="66700c71-4b67-4d05-a025-65cca66a2d9e" providerId="ADAL" clId="{40447571-E4A6-4F32-A1D1-C8BB8A79932B}" dt="2026-06-01T12:02:12.790" v="530" actId="20577"/>
+          <ac:chgData name="Ulrik Steen Andersen" userId="66700c71-4b67-4d05-a025-65cca66a2d9e" providerId="ADAL" clId="{40447571-E4A6-4F32-A1D1-C8BB8A79932B}" dt="2026-06-01T12:22:44.517" v="725" actId="20577"/>
           <ac:spMkLst>
             <pc:docMk/>
             <pc:sldMk cId="4046370384" sldId="262"/>
             <ac:spMk id="5" creationId="{5EF8A989-D133-115B-C69C-ED32AC92500D}"/>
           </ac:spMkLst>
         </pc:spChg>
+      </pc:sldChg>
+      <pc:sldChg chg="new">
+        <pc:chgData name="Ulrik Steen Andersen" userId="66700c71-4b67-4d05-a025-65cca66a2d9e" providerId="ADAL" clId="{40447571-E4A6-4F32-A1D1-C8BB8A79932B}" dt="2026-06-01T12:33:05.025" v="726" actId="680"/>
+        <pc:sldMkLst>
+          <pc:docMk/>
+          <pc:sldMk cId="3848539155" sldId="263"/>
+        </pc:sldMkLst>
+      </pc:sldChg>
+      <pc:sldChg chg="new">
+        <pc:chgData name="Ulrik Steen Andersen" userId="66700c71-4b67-4d05-a025-65cca66a2d9e" providerId="ADAL" clId="{40447571-E4A6-4F32-A1D1-C8BB8A79932B}" dt="2026-06-01T12:33:06.231" v="727" actId="680"/>
+        <pc:sldMkLst>
+          <pc:docMk/>
+          <pc:sldMk cId="4176369601" sldId="264"/>
+        </pc:sldMkLst>
       </pc:sldChg>
     </pc:docChg>
   </pc:docChgLst>
@@ -3855,7 +3951,12 @@
             <p:ph type="title"/>
           </p:nvPr>
         </p:nvSpPr>
-        <p:spPr/>
+        <p:spPr>
+          <a:xfrm>
+            <a:off x="838200" y="176981"/>
+            <a:ext cx="10515600" cy="943897"/>
+          </a:xfrm>
+        </p:spPr>
         <p:txBody>
           <a:bodyPr/>
           <a:lstStyle/>
@@ -3868,31 +3969,44 @@
           </a:p>
         </p:txBody>
       </p:sp>
-      <p:sp>
-        <p:nvSpPr>
-          <p:cNvPr id="3" name="Content Placeholder 2">
-            <a:extLst>
-              <a:ext uri="{FF2B5EF4-FFF2-40B4-BE49-F238E27FC236}">
-                <a16:creationId xmlns:a16="http://schemas.microsoft.com/office/drawing/2014/main" id="{EC28A938-EDEC-EB58-0B84-D2AF20C753E7}"/>
-              </a:ext>
-            </a:extLst>
-          </p:cNvPr>
-          <p:cNvSpPr>
-            <a:spLocks noGrp="1"/>
-          </p:cNvSpPr>
+      <p:pic>
+        <p:nvPicPr>
+          <p:cNvPr id="5" name="Content Placeholder 4">
+            <a:extLst>
+              <a:ext uri="{FF2B5EF4-FFF2-40B4-BE49-F238E27FC236}">
+                <a16:creationId xmlns:a16="http://schemas.microsoft.com/office/drawing/2014/main" id="{ECF230BF-30BC-7678-54DF-27651DC18941}"/>
+              </a:ext>
+            </a:extLst>
+          </p:cNvPr>
+          <p:cNvPicPr>
+            <a:picLocks noGrp="1" noChangeAspect="1"/>
+          </p:cNvPicPr>
           <p:nvPr>
             <p:ph idx="1"/>
           </p:nvPr>
-        </p:nvSpPr>
-        <p:spPr/>
-        <p:txBody>
-          <a:bodyPr/>
-          <a:lstStyle/>
-          <a:p>
-            <a:endParaRPr lang="en-DK"/>
-          </a:p>
-        </p:txBody>
-      </p:sp>
+        </p:nvPicPr>
+        <p:blipFill>
+          <a:blip r:embed="rId2">
+            <a:extLst>
+              <a:ext uri="{28A0092B-C50C-407E-A947-70E740481C1C}">
+                <a14:useLocalDpi xmlns:a14="http://schemas.microsoft.com/office/drawing/2010/main" val="0"/>
+              </a:ext>
+            </a:extLst>
+          </a:blip>
+          <a:stretch>
+            <a:fillRect/>
+          </a:stretch>
+        </p:blipFill>
+        <p:spPr>
+          <a:xfrm>
+            <a:off x="1484526" y="1120878"/>
+            <a:ext cx="9222947" cy="5560141"/>
+          </a:xfrm>
+          <a:prstGeom prst="rect">
+            <a:avLst/>
+          </a:prstGeom>
+        </p:spPr>
+      </p:pic>
     </p:spTree>
     <p:extLst>
       <p:ext uri="{BB962C8B-B14F-4D97-AF65-F5344CB8AC3E}">
@@ -3974,12 +4088,14 @@
         </p:nvSpPr>
         <p:spPr/>
         <p:txBody>
-          <a:bodyPr/>
+          <a:bodyPr>
+            <a:normAutofit lnSpcReduction="10000"/>
+          </a:bodyPr>
           <a:lstStyle/>
           <a:p>
             <a:r>
               <a:rPr lang="en-US" dirty="0"/>
-              <a:t>Hungarian </a:t>
+              <a:t>Typical Hungarian </a:t>
             </a:r>
             <a:r>
               <a:rPr lang="en-US" dirty="0" err="1"/>
@@ -3993,6 +4109,16 @@
               <a:rPr lang="en-US" dirty="0" err="1"/>
               <a:t>deszka</a:t>
             </a:r>
+            <a:r>
+              <a:rPr lang="en-US" dirty="0"/>
+              <a:t>,</a:t>
+            </a:r>
+          </a:p>
+          <a:p>
+            <a:r>
+              <a:rPr lang="en-US" dirty="0"/>
+              <a:t>Average rating  = (25.12±12.78) %</a:t>
+            </a:r>
             <a:endParaRPr lang="en-DK" dirty="0"/>
           </a:p>
         </p:txBody>
@@ -4040,14 +4166,21 @@
         </p:nvSpPr>
         <p:spPr/>
         <p:txBody>
-          <a:bodyPr/>
+          <a:bodyPr>
+            <a:normAutofit lnSpcReduction="10000"/>
+          </a:bodyPr>
           <a:lstStyle/>
           <a:p>
             <a:r>
               <a:rPr lang="en-US" dirty="0"/>
-              <a:t>Korean</a:t>
-            </a:r>
-            <a:endParaRPr lang="en-DK" dirty="0"/>
+              <a:t>Typical Korean</a:t>
+            </a:r>
+          </a:p>
+          <a:p>
+            <a:r>
+              <a:rPr lang="en-US" dirty="0"/>
+              <a:t>Average rating = (78.85 ±15.08) %</a:t>
+            </a:r>
           </a:p>
         </p:txBody>
       </p:sp>
@@ -4127,6 +4260,14 @@
           <a:bodyPr/>
           <a:lstStyle/>
           <a:p>
+            <a:r>
+              <a:rPr lang="en-US" dirty="0" err="1"/>
+              <a:t>Scrandle</a:t>
+            </a:r>
+            <a:r>
+              <a:rPr lang="en-US" dirty="0"/>
+              <a:t> Predictor</a:t>
+            </a:r>
             <a:endParaRPr lang="en-DK" dirty="0"/>
           </a:p>
         </p:txBody>
@@ -4160,6 +4301,166 @@
     <p:extLst>
       <p:ext uri="{BB962C8B-B14F-4D97-AF65-F5344CB8AC3E}">
         <p14:creationId xmlns:p14="http://schemas.microsoft.com/office/powerpoint/2010/main" val="2214895637"/>
+      </p:ext>
+    </p:extLst>
+  </p:cSld>
+  <p:clrMapOvr>
+    <a:masterClrMapping/>
+  </p:clrMapOvr>
+</p:sld>
+</file>
+
+<file path=ppt/slides/slide8.xml><?xml version="1.0" encoding="utf-8"?>
+<p:sld xmlns:a="http://schemas.openxmlformats.org/drawingml/2006/main" xmlns:r="http://schemas.openxmlformats.org/officeDocument/2006/relationships" xmlns:p="http://schemas.openxmlformats.org/presentationml/2006/main">
+  <p:cSld>
+    <p:spTree>
+      <p:nvGrpSpPr>
+        <p:cNvPr id="1" name=""/>
+        <p:cNvGrpSpPr/>
+        <p:nvPr/>
+      </p:nvGrpSpPr>
+      <p:grpSpPr>
+        <a:xfrm>
+          <a:off x="0" y="0"/>
+          <a:ext cx="0" cy="0"/>
+          <a:chOff x="0" y="0"/>
+          <a:chExt cx="0" cy="0"/>
+        </a:xfrm>
+      </p:grpSpPr>
+      <p:sp>
+        <p:nvSpPr>
+          <p:cNvPr id="2" name="Title 1">
+            <a:extLst>
+              <a:ext uri="{FF2B5EF4-FFF2-40B4-BE49-F238E27FC236}">
+                <a16:creationId xmlns:a16="http://schemas.microsoft.com/office/drawing/2014/main" id="{DC4122E0-EB43-C33C-A5B9-6E6D49FF1B49}"/>
+              </a:ext>
+            </a:extLst>
+          </p:cNvPr>
+          <p:cNvSpPr>
+            <a:spLocks noGrp="1"/>
+          </p:cNvSpPr>
+          <p:nvPr>
+            <p:ph type="ctrTitle"/>
+          </p:nvPr>
+        </p:nvSpPr>
+        <p:spPr/>
+        <p:txBody>
+          <a:bodyPr/>
+          <a:lstStyle/>
+          <a:p>
+            <a:endParaRPr lang="en-DK"/>
+          </a:p>
+        </p:txBody>
+      </p:sp>
+      <p:sp>
+        <p:nvSpPr>
+          <p:cNvPr id="3" name="Subtitle 2">
+            <a:extLst>
+              <a:ext uri="{FF2B5EF4-FFF2-40B4-BE49-F238E27FC236}">
+                <a16:creationId xmlns:a16="http://schemas.microsoft.com/office/drawing/2014/main" id="{ED8A1794-99C9-F8FA-C0A8-8056BC228339}"/>
+              </a:ext>
+            </a:extLst>
+          </p:cNvPr>
+          <p:cNvSpPr>
+            <a:spLocks noGrp="1"/>
+          </p:cNvSpPr>
+          <p:nvPr>
+            <p:ph type="subTitle" idx="1"/>
+          </p:nvPr>
+        </p:nvSpPr>
+        <p:spPr/>
+        <p:txBody>
+          <a:bodyPr/>
+          <a:lstStyle/>
+          <a:p>
+            <a:endParaRPr lang="en-DK"/>
+          </a:p>
+        </p:txBody>
+      </p:sp>
+    </p:spTree>
+    <p:extLst>
+      <p:ext uri="{BB962C8B-B14F-4D97-AF65-F5344CB8AC3E}">
+        <p14:creationId xmlns:p14="http://schemas.microsoft.com/office/powerpoint/2010/main" val="3848539155"/>
+      </p:ext>
+    </p:extLst>
+  </p:cSld>
+  <p:clrMapOvr>
+    <a:masterClrMapping/>
+  </p:clrMapOvr>
+</p:sld>
+</file>
+
+<file path=ppt/slides/slide9.xml><?xml version="1.0" encoding="utf-8"?>
+<p:sld xmlns:a="http://schemas.openxmlformats.org/drawingml/2006/main" xmlns:r="http://schemas.openxmlformats.org/officeDocument/2006/relationships" xmlns:p="http://schemas.openxmlformats.org/presentationml/2006/main">
+  <p:cSld>
+    <p:spTree>
+      <p:nvGrpSpPr>
+        <p:cNvPr id="1" name=""/>
+        <p:cNvGrpSpPr/>
+        <p:nvPr/>
+      </p:nvGrpSpPr>
+      <p:grpSpPr>
+        <a:xfrm>
+          <a:off x="0" y="0"/>
+          <a:ext cx="0" cy="0"/>
+          <a:chOff x="0" y="0"/>
+          <a:chExt cx="0" cy="0"/>
+        </a:xfrm>
+      </p:grpSpPr>
+      <p:sp>
+        <p:nvSpPr>
+          <p:cNvPr id="2" name="Title 1">
+            <a:extLst>
+              <a:ext uri="{FF2B5EF4-FFF2-40B4-BE49-F238E27FC236}">
+                <a16:creationId xmlns:a16="http://schemas.microsoft.com/office/drawing/2014/main" id="{D71B2409-B537-4B51-822E-A3E7DF515876}"/>
+              </a:ext>
+            </a:extLst>
+          </p:cNvPr>
+          <p:cNvSpPr>
+            <a:spLocks noGrp="1"/>
+          </p:cNvSpPr>
+          <p:nvPr>
+            <p:ph type="ctrTitle"/>
+          </p:nvPr>
+        </p:nvSpPr>
+        <p:spPr/>
+        <p:txBody>
+          <a:bodyPr/>
+          <a:lstStyle/>
+          <a:p>
+            <a:endParaRPr lang="en-DK"/>
+          </a:p>
+        </p:txBody>
+      </p:sp>
+      <p:sp>
+        <p:nvSpPr>
+          <p:cNvPr id="3" name="Subtitle 2">
+            <a:extLst>
+              <a:ext uri="{FF2B5EF4-FFF2-40B4-BE49-F238E27FC236}">
+                <a16:creationId xmlns:a16="http://schemas.microsoft.com/office/drawing/2014/main" id="{47B74358-106C-DFAE-1254-F53E70414538}"/>
+              </a:ext>
+            </a:extLst>
+          </p:cNvPr>
+          <p:cNvSpPr>
+            <a:spLocks noGrp="1"/>
+          </p:cNvSpPr>
+          <p:nvPr>
+            <p:ph type="subTitle" idx="1"/>
+          </p:nvPr>
+        </p:nvSpPr>
+        <p:spPr/>
+        <p:txBody>
+          <a:bodyPr/>
+          <a:lstStyle/>
+          <a:p>
+            <a:endParaRPr lang="en-DK"/>
+          </a:p>
+        </p:txBody>
+      </p:sp>
+    </p:spTree>
+    <p:extLst>
+      <p:ext uri="{BB962C8B-B14F-4D97-AF65-F5344CB8AC3E}">
+        <p14:creationId xmlns:p14="http://schemas.microsoft.com/office/powerpoint/2010/main" val="4176369601"/>
       </p:ext>
     </p:extLst>
   </p:cSld>

</xml_diff>